<commit_message>
Fix slide footer formatting and bullet numbering across PDF and PPTX
</commit_message>
<xml_diff>
--- a/presentation/GLYCOTWIN_PRESENTATION.pptx
+++ b/presentation/GLYCOTWIN_PRESENTATION.pptx
@@ -3678,7 +3678,7 @@
               </a:defRPr>
             </a:pPr>
             <a:r>
-              <a:t>Thank You • Happiest Health Summit 2026 Bengaluru  |  Slide 10 of 10</a:t>
+              <a:t>Happiest Health Summit 2026 • Bengaluru  |  Slide 10 of 10</a:t>
             </a:r>
           </a:p>
         </p:txBody>
@@ -3988,7 +3988,7 @@
               </a:defRPr>
             </a:pPr>
             <a:r>
-              <a:t>Clinical Background • Slide 2 of 10  |  Slide 2 of 10</a:t>
+              <a:t>Clinical Background &amp; Context  |  Slide 2 of 10</a:t>
             </a:r>
           </a:p>
         </p:txBody>
@@ -4266,7 +4266,7 @@
               </a:defRPr>
             </a:pPr>
             <a:r>
-              <a:t>Data Architecture • Slide 3 of 10  |  Slide 3 of 10</a:t>
+              <a:t>Data Architecture &amp; Privacy  |  Slide 3 of 10</a:t>
             </a:r>
           </a:p>
         </p:txBody>
@@ -4608,7 +4608,7 @@
               </a:defRPr>
             </a:pPr>
             <a:r>
-              <a:t>Model Evaluation • Slide 4 of 10  |  Slide 4 of 10</a:t>
+              <a:t>Model Evaluation &amp; Benchmarking  |  Slide 4 of 10</a:t>
             </a:r>
           </a:p>
         </p:txBody>
@@ -4828,13 +4828,13 @@
               </a:spcAft>
               <a:defRPr sz="1300">
                 <a:solidFill>
-                  <a:srgbClr val="FDE68A"/>
-                </a:solidFill>
-                <a:latin typeface="Arial"/>
-              </a:defRPr>
-            </a:pPr>
-            <a:r>
-              <a:t>   1. Post-Prandial Brisk Walk (0 to 45 mins): Simulates muscular GLUT-4 glucose clearance.</a:t>
+                  <a:srgbClr val="94A3B8"/>
+                </a:solidFill>
+                <a:latin typeface="Arial"/>
+              </a:defRPr>
+            </a:pPr>
+            <a:r>
+              <a:t>   • Post-Prandial Brisk Walk (0 to 45 mins): Simulates muscular GLUT-4 glucose clearance.</a:t>
             </a:r>
           </a:p>
           <a:p>
@@ -4844,13 +4844,13 @@
               </a:spcAft>
               <a:defRPr sz="1300">
                 <a:solidFill>
-                  <a:srgbClr val="FDE68A"/>
-                </a:solidFill>
-                <a:latin typeface="Arial"/>
-              </a:defRPr>
-            </a:pPr>
-            <a:r>
-              <a:t>   2. Indian Carb Swap / Reduction (0 to 60g): Models switching white rice to millets/proteins.</a:t>
+                  <a:srgbClr val="94A3B8"/>
+                </a:solidFill>
+                <a:latin typeface="Arial"/>
+              </a:defRPr>
+            </a:pPr>
+            <a:r>
+              <a:t>   • Indian Carb Swap / Reduction (0 to 60g): Models switching white rice to millets/proteins.</a:t>
             </a:r>
           </a:p>
           <a:p>
@@ -4860,13 +4860,13 @@
               </a:spcAft>
               <a:defRPr sz="1300">
                 <a:solidFill>
-                  <a:srgbClr val="FDE68A"/>
-                </a:solidFill>
-                <a:latin typeface="Arial"/>
-              </a:defRPr>
-            </a:pPr>
-            <a:r>
-              <a:t>   3. Medication Adjustment (-4U to +4U): Titrates basal insulin or shifts sulfonylurea timing.</a:t>
+                  <a:srgbClr val="94A3B8"/>
+                </a:solidFill>
+                <a:latin typeface="Arial"/>
+              </a:defRPr>
+            </a:pPr>
+            <a:r>
+              <a:t>   • Medication Adjustment (-4U to +4U): Titrates basal insulin or shifts sulfonylurea timing.</a:t>
             </a:r>
           </a:p>
           <a:p>
@@ -4918,7 +4918,7 @@
               </a:defRPr>
             </a:pPr>
             <a:r>
-              <a:t>Counterfactual Simulation • Slide 5 of 10  |  Slide 5 of 10</a:t>
+              <a:t>In-Silico Counterfactual Simulation  |  Slide 5 of 10</a:t>
             </a:r>
           </a:p>
         </p:txBody>
@@ -5228,7 +5228,7 @@
               </a:defRPr>
             </a:pPr>
             <a:r>
-              <a:t>User Interface &amp; Experience • Slide 6 of 10  |  Slide 6 of 10</a:t>
+              <a:t>User Interface &amp; Cockpit  |  Slide 6 of 10</a:t>
             </a:r>
           </a:p>
         </p:txBody>
@@ -5570,7 +5570,7 @@
               </a:defRPr>
             </a:pPr>
             <a:r>
-              <a:t>Clinical Validation • Slide 7 of 10  |  Slide 7 of 10</a:t>
+              <a:t>Clinical Scenarios &amp; Persona Validation  |  Slide 7 of 10</a:t>
             </a:r>
           </a:p>
         </p:txBody>
@@ -5864,7 +5864,7 @@
               </a:defRPr>
             </a:pPr>
             <a:r>
-              <a:t>Regulatory Compliance • Slide 8 of 10  |  Slide 8 of 10</a:t>
+              <a:t>Regulatory Compliance &amp; Sandbox Rules  |  Slide 8 of 10</a:t>
             </a:r>
           </a:p>
         </p:txBody>
@@ -6190,7 +6190,7 @@
               </a:defRPr>
             </a:pPr>
             <a:r>
-              <a:t>Deployment Roadmap • Slide 9 of 10  |  Slide 9 of 10</a:t>
+              <a:t>Impact &amp; Deployment Roadmap  |  Slide 9 of 10</a:t>
             </a:r>
           </a:p>
         </p:txBody>

</xml_diff>